<commit_message>
Strengthen deck with food-insecurity data and Grow-to-Give phase
Slide 2 now leads with the USDA 2024 stat (14.1M children, ~6 per class
of 30) and adds Grow-to-Give as a highlighted fourth story phase; the
VOC slide subtitle carries the stat as backdrop context.

Co-Authored-By: Claude Fable 5 <noreply@anthropic.com>
Claude-Session: https://claude.ai/code/session_01Q5Di2GdWCoun7eV8DBegc6
</commit_message>
<xml_diff>
--- a/pitch/FarmQuest_Pitch.pptx
+++ b/pitch/FarmQuest_Pitch.pptx
@@ -2154,11 +2154,11 @@
         <p:spPr>
           <a:xfrm>
             <a:off x="548640" y="1325880"/>
-            <a:ext cx="5394960" cy="2377440"/>
+            <a:ext cx="5394960" cy="2697480"/>
           </a:xfrm>
           <a:prstGeom prst="roundRect">
             <a:avLst>
-              <a:gd name="adj" fmla="val 3462"/>
+              <a:gd name="adj" fmla="val 3051"/>
             </a:avLst>
           </a:prstGeom>
           <a:solidFill>
@@ -2180,7 +2180,7 @@
         </p:nvSpPr>
         <p:spPr>
           <a:xfrm>
-            <a:off x="868680" y="1536192"/>
+            <a:off x="868680" y="1517904"/>
             <a:ext cx="4754880" cy="274320"/>
           </a:xfrm>
           <a:prstGeom prst="rect">
@@ -2219,51 +2219,129 @@
         </p:nvSpPr>
         <p:spPr>
           <a:xfrm>
-            <a:off x="868680" y="1828800"/>
-            <a:ext cx="4754880" cy="1737360"/>
-          </a:xfrm>
-          <a:prstGeom prst="rect">
-            <a:avLst/>
-          </a:prstGeom>
-          <a:noFill/>
-          <a:ln/>
-        </p:spPr>
-        <p:txBody>
-          <a:bodyPr wrap="square" lIns="0" tIns="0" rIns="0" bIns="0" rtlCol="0" anchor="ctr"/>
-          <a:lstStyle/>
-          <a:p>
-            <a:pPr indent="0" marL="0">
-              <a:buNone/>
-            </a:pPr>
-            <a:r>
-              <a:rPr lang="en-US" sz="1300" dirty="0">
-                <a:solidFill>
-                  <a:srgbClr val="EEF5EF"/>
+            <a:off x="868680" y="1810512"/>
+            <a:ext cx="1737360" cy="685800"/>
+          </a:xfrm>
+          <a:prstGeom prst="rect">
+            <a:avLst/>
+          </a:prstGeom>
+          <a:noFill/>
+          <a:ln/>
+        </p:spPr>
+        <p:txBody>
+          <a:bodyPr wrap="square" lIns="0" tIns="0" rIns="0" bIns="0" rtlCol="0" anchor="ctr"/>
+          <a:lstStyle/>
+          <a:p>
+            <a:pPr indent="0" marL="0">
+              <a:buNone/>
+            </a:pPr>
+            <a:r>
+              <a:rPr lang="en-US" sz="3800" b="1" dirty="0">
+                <a:solidFill>
+                  <a:srgbClr val="F5B942"/>
+                </a:solidFill>
+                <a:latin typeface="Arial" pitchFamily="34" charset="0"/>
+                <a:ea typeface="Arial" pitchFamily="34" charset="-122"/>
+                <a:cs typeface="Arial" pitchFamily="34" charset="-120"/>
+              </a:rPr>
+              <a:t>14.1M</a:t>
+            </a:r>
+            <a:endParaRPr lang="en-US" sz="3800" dirty="0"/>
+          </a:p>
+        </p:txBody>
+      </p:sp>
+      <p:sp>
+        <p:nvSpPr>
+          <p:cNvPr id="7" name="Text 5"/>
+          <p:cNvSpPr/>
+          <p:nvPr/>
+        </p:nvSpPr>
+        <p:spPr>
+          <a:xfrm>
+            <a:off x="2743200" y="1847088"/>
+            <a:ext cx="2926080" cy="777240"/>
+          </a:xfrm>
+          <a:prstGeom prst="rect">
+            <a:avLst/>
+          </a:prstGeom>
+          <a:noFill/>
+          <a:ln/>
+        </p:spPr>
+        <p:txBody>
+          <a:bodyPr wrap="square" lIns="0" tIns="0" rIns="0" bIns="0" rtlCol="0" anchor="ctr"/>
+          <a:lstStyle/>
+          <a:p>
+            <a:pPr indent="0" marL="0">
+              <a:buNone/>
+            </a:pPr>
+            <a:r>
+              <a:rPr lang="en-US" sz="1050" dirty="0">
+                <a:solidFill>
+                  <a:srgbClr val="F8D183"/>
                 </a:solidFill>
                 <a:latin typeface="Calibri" pitchFamily="34" charset="0"/>
                 <a:ea typeface="Calibri" pitchFamily="34" charset="-122"/>
                 <a:cs typeface="Calibri" pitchFamily="34" charset="-120"/>
               </a:rPr>
-              <a:t>Food insecurity is taught as a statistic and toured as a walk-through. The one day students spend at a real farm produces neither understanding nor empathy — and teachers can't fix it without building custom materials they have no time to build.</a:t>
-            </a:r>
-            <a:endParaRPr lang="en-US" sz="1300" dirty="0"/>
-          </a:p>
-        </p:txBody>
-      </p:sp>
-      <p:sp>
-        <p:nvSpPr>
-          <p:cNvPr id="7" name="Shape 5"/>
-          <p:cNvSpPr/>
-          <p:nvPr/>
-        </p:nvSpPr>
-        <p:spPr>
-          <a:xfrm>
-            <a:off x="548640" y="3886200"/>
-            <a:ext cx="5394960" cy="1965960"/>
+              <a:t>children live in food-insecure households — about 6 in every class of 30. (USDA 2024, the final federal survey.)</a:t>
+            </a:r>
+            <a:endParaRPr lang="en-US" sz="1050" dirty="0"/>
+          </a:p>
+        </p:txBody>
+      </p:sp>
+      <p:sp>
+        <p:nvSpPr>
+          <p:cNvPr id="8" name="Text 6"/>
+          <p:cNvSpPr/>
+          <p:nvPr/>
+        </p:nvSpPr>
+        <p:spPr>
+          <a:xfrm>
+            <a:off x="868680" y="2697480"/>
+            <a:ext cx="4754880" cy="1234440"/>
+          </a:xfrm>
+          <a:prstGeom prst="rect">
+            <a:avLst/>
+          </a:prstGeom>
+          <a:noFill/>
+          <a:ln/>
+        </p:spPr>
+        <p:txBody>
+          <a:bodyPr wrap="square" lIns="0" tIns="0" rIns="0" bIns="0" rtlCol="0" anchor="ctr"/>
+          <a:lstStyle/>
+          <a:p>
+            <a:pPr indent="0" marL="0">
+              <a:buNone/>
+            </a:pPr>
+            <a:r>
+              <a:rPr lang="en-US" sz="1250" dirty="0">
+                <a:solidFill>
+                  <a:srgbClr val="EEF5EF"/>
+                </a:solidFill>
+                <a:latin typeface="Calibri" pitchFamily="34" charset="0"/>
+                <a:ea typeface="Calibri" pitchFamily="34" charset="-122"/>
+                <a:cs typeface="Calibri" pitchFamily="34" charset="-120"/>
+              </a:rPr>
+              <a:t>Yet food insecurity is taught as a statistic and toured as a walk-through — abstract to students who don't live it, quietly stigmatizing to those who do. Teachers can't fix it without custom materials they have no time to build.</a:t>
+            </a:r>
+            <a:endParaRPr lang="en-US" sz="1250" dirty="0"/>
+          </a:p>
+        </p:txBody>
+      </p:sp>
+      <p:sp>
+        <p:nvSpPr>
+          <p:cNvPr id="9" name="Shape 7"/>
+          <p:cNvSpPr/>
+          <p:nvPr/>
+        </p:nvSpPr>
+        <p:spPr>
+          <a:xfrm>
+            <a:off x="548640" y="4206240"/>
+            <a:ext cx="5394960" cy="1810512"/>
           </a:xfrm>
           <a:prstGeom prst="roundRect">
             <a:avLst>
-              <a:gd name="adj" fmla="val 4186"/>
+              <a:gd name="adj" fmla="val 4545"/>
             </a:avLst>
           </a:prstGeom>
           <a:solidFill>
@@ -2279,13 +2357,13 @@
       </p:sp>
       <p:sp>
         <p:nvSpPr>
-          <p:cNvPr id="8" name="Text 6"/>
-          <p:cNvSpPr/>
-          <p:nvPr/>
-        </p:nvSpPr>
-        <p:spPr>
-          <a:xfrm>
-            <a:off x="868680" y="4096512"/>
+          <p:cNvPr id="10" name="Text 8"/>
+          <p:cNvSpPr/>
+          <p:nvPr/>
+        </p:nvSpPr>
+        <p:spPr>
+          <a:xfrm>
+            <a:off x="868680" y="4389120"/>
             <a:ext cx="4754880" cy="274320"/>
           </a:xfrm>
           <a:prstGeom prst="rect">
@@ -2318,30 +2396,30 @@
       </p:sp>
       <p:sp>
         <p:nvSpPr>
-          <p:cNvPr id="9" name="Text 7"/>
-          <p:cNvSpPr/>
-          <p:nvPr/>
-        </p:nvSpPr>
-        <p:spPr>
-          <a:xfrm>
-            <a:off x="868680" y="4389120"/>
-            <a:ext cx="4754880" cy="1371600"/>
-          </a:xfrm>
-          <a:prstGeom prst="rect">
-            <a:avLst/>
-          </a:prstGeom>
-          <a:noFill/>
-          <a:ln/>
-        </p:spPr>
-        <p:txBody>
-          <a:bodyPr wrap="square" lIns="0" tIns="0" rIns="0" bIns="0" rtlCol="0" anchor="ctr"/>
-          <a:lstStyle/>
-          <a:p>
-            <a:pPr indent="0" marL="0">
-              <a:buNone/>
-            </a:pPr>
-            <a:r>
-              <a:rPr lang="en-US" sz="1300" dirty="0">
+          <p:cNvPr id="11" name="Text 9"/>
+          <p:cNvSpPr/>
+          <p:nvPr/>
+        </p:nvSpPr>
+        <p:spPr>
+          <a:xfrm>
+            <a:off x="868680" y="4681728"/>
+            <a:ext cx="4754880" cy="1280160"/>
+          </a:xfrm>
+          <a:prstGeom prst="rect">
+            <a:avLst/>
+          </a:prstGeom>
+          <a:noFill/>
+          <a:ln/>
+        </p:spPr>
+        <p:txBody>
+          <a:bodyPr wrap="square" lIns="0" tIns="0" rIns="0" bIns="0" rtlCol="0" anchor="ctr"/>
+          <a:lstStyle/>
+          <a:p>
+            <a:pPr indent="0" marL="0">
+              <a:buNone/>
+            </a:pPr>
+            <a:r>
+              <a:rPr lang="en-US" sz="1250" dirty="0">
                 <a:solidFill>
                   <a:srgbClr val="EEF5EF"/>
                 </a:solidFill>
@@ -2349,26 +2427,26 @@
                 <a:ea typeface="Calibri" pitchFamily="34" charset="-122"/>
                 <a:cs typeface="Calibri" pitchFamily="34" charset="-120"/>
               </a:rPr>
-              <a:t>A branching story game: AI-drafted per farm and class, machine-moderated, teacher-approved before any student plays. Chapters unlock via QR codes at real farm stations — the clues live in the physical world.</a:t>
-            </a:r>
-            <a:endParaRPr lang="en-US" sz="1300" dirty="0"/>
-          </a:p>
-        </p:txBody>
-      </p:sp>
-      <p:sp>
-        <p:nvSpPr>
-          <p:cNvPr id="10" name="Shape 8"/>
+              <a:t>A branching story game — AI-drafted per farm and class, teacher-approved before any student plays. Chapters unlock via QR codes at real farm stations, and Grow-to-Give continues the story into a class garden that feeds food-insecure neighbors.</a:t>
+            </a:r>
+            <a:endParaRPr lang="en-US" sz="1250" dirty="0"/>
+          </a:p>
+        </p:txBody>
+      </p:sp>
+      <p:sp>
+        <p:nvSpPr>
+          <p:cNvPr id="12" name="Shape 10"/>
           <p:cNvSpPr/>
           <p:nvPr/>
         </p:nvSpPr>
         <p:spPr>
           <a:xfrm>
             <a:off x="6263640" y="1325880"/>
-            <a:ext cx="5394960" cy="1261872"/>
+            <a:ext cx="5394960" cy="1060704"/>
           </a:xfrm>
           <a:prstGeom prst="roundRect">
             <a:avLst>
-              <a:gd name="adj" fmla="val 6522"/>
+              <a:gd name="adj" fmla="val 7759"/>
             </a:avLst>
           </a:prstGeom>
           <a:solidFill>
@@ -2384,14 +2462,14 @@
       </p:sp>
       <p:sp>
         <p:nvSpPr>
-          <p:cNvPr id="11" name="Shape 9"/>
-          <p:cNvSpPr/>
-          <p:nvPr/>
-        </p:nvSpPr>
-        <p:spPr>
-          <a:xfrm>
-            <a:off x="6492240" y="1709928"/>
-            <a:ext cx="502920" cy="502920"/>
+          <p:cNvPr id="13" name="Shape 11"/>
+          <p:cNvSpPr/>
+          <p:nvPr/>
+        </p:nvSpPr>
+        <p:spPr>
+          <a:xfrm>
+            <a:off x="6492240" y="1618488"/>
+            <a:ext cx="457200" cy="457200"/>
           </a:xfrm>
           <a:prstGeom prst="ellipse">
             <a:avLst/>
@@ -2409,14 +2487,14 @@
       </p:sp>
       <p:sp>
         <p:nvSpPr>
-          <p:cNvPr id="12" name="Text 10"/>
-          <p:cNvSpPr/>
-          <p:nvPr/>
-        </p:nvSpPr>
-        <p:spPr>
-          <a:xfrm>
-            <a:off x="6492240" y="1709928"/>
-            <a:ext cx="502920" cy="502920"/>
+          <p:cNvPr id="14" name="Text 12"/>
+          <p:cNvSpPr/>
+          <p:nvPr/>
+        </p:nvSpPr>
+        <p:spPr>
+          <a:xfrm>
+            <a:off x="6492240" y="1618488"/>
+            <a:ext cx="457200" cy="457200"/>
           </a:xfrm>
           <a:prstGeom prst="rect">
             <a:avLst/>
@@ -2432,7 +2510,7 @@
               <a:buNone/>
             </a:pPr>
             <a:r>
-              <a:rPr lang="en-US" sz="1800" b="1" dirty="0">
+              <a:rPr lang="en-US" sz="1600" b="1" dirty="0">
                 <a:solidFill>
                   <a:srgbClr val="F5B942"/>
                 </a:solidFill>
@@ -2442,36 +2520,36 @@
               </a:rPr>
               <a:t>1</a:t>
             </a:r>
-            <a:endParaRPr lang="en-US" sz="1800" dirty="0"/>
-          </a:p>
-        </p:txBody>
-      </p:sp>
-      <p:sp>
-        <p:nvSpPr>
-          <p:cNvPr id="13" name="Text 11"/>
-          <p:cNvSpPr/>
-          <p:nvPr/>
-        </p:nvSpPr>
-        <p:spPr>
-          <a:xfrm>
-            <a:off x="7178040" y="1472184"/>
-            <a:ext cx="4343400" cy="292608"/>
-          </a:xfrm>
-          <a:prstGeom prst="rect">
-            <a:avLst/>
-          </a:prstGeom>
-          <a:noFill/>
-          <a:ln/>
-        </p:spPr>
-        <p:txBody>
-          <a:bodyPr wrap="square" lIns="0" tIns="0" rIns="0" bIns="0" rtlCol="0" anchor="ctr"/>
-          <a:lstStyle/>
-          <a:p>
-            <a:pPr indent="0" marL="0">
-              <a:buNone/>
-            </a:pPr>
-            <a:r>
-              <a:rPr lang="en-US" sz="1400" b="1" dirty="0">
+            <a:endParaRPr lang="en-US" sz="1600" dirty="0"/>
+          </a:p>
+        </p:txBody>
+      </p:sp>
+      <p:sp>
+        <p:nvSpPr>
+          <p:cNvPr id="15" name="Text 13"/>
+          <p:cNvSpPr/>
+          <p:nvPr/>
+        </p:nvSpPr>
+        <p:spPr>
+          <a:xfrm>
+            <a:off x="7132320" y="1435608"/>
+            <a:ext cx="4389120" cy="274320"/>
+          </a:xfrm>
+          <a:prstGeom prst="rect">
+            <a:avLst/>
+          </a:prstGeom>
+          <a:noFill/>
+          <a:ln/>
+        </p:spPr>
+        <p:txBody>
+          <a:bodyPr wrap="square" lIns="0" tIns="0" rIns="0" bIns="0" rtlCol="0" anchor="ctr"/>
+          <a:lstStyle/>
+          <a:p>
+            <a:pPr indent="0" marL="0">
+              <a:buNone/>
+            </a:pPr>
+            <a:r>
+              <a:rPr lang="en-US" sz="1300" b="1" dirty="0">
                 <a:solidFill>
                   <a:srgbClr val="F8D183"/>
                 </a:solidFill>
@@ -2481,36 +2559,36 @@
               </a:rPr>
               <a:t>In class — the setup</a:t>
             </a:r>
-            <a:endParaRPr lang="en-US" sz="1400" dirty="0"/>
-          </a:p>
-        </p:txBody>
-      </p:sp>
-      <p:sp>
-        <p:nvSpPr>
-          <p:cNvPr id="14" name="Text 12"/>
-          <p:cNvSpPr/>
-          <p:nvPr/>
-        </p:nvSpPr>
-        <p:spPr>
-          <a:xfrm>
-            <a:off x="7178040" y="1783080"/>
-            <a:ext cx="4343400" cy="731520"/>
-          </a:xfrm>
-          <a:prstGeom prst="rect">
-            <a:avLst/>
-          </a:prstGeom>
-          <a:noFill/>
-          <a:ln/>
-        </p:spPr>
-        <p:txBody>
-          <a:bodyPr wrap="square" lIns="0" tIns="0" rIns="0" bIns="0" rtlCol="0" anchor="ctr"/>
-          <a:lstStyle/>
-          <a:p>
-            <a:pPr indent="0" marL="0">
-              <a:buNone/>
-            </a:pPr>
-            <a:r>
-              <a:rPr lang="en-US" sz="1150" dirty="0">
+            <a:endParaRPr lang="en-US" sz="1300" dirty="0"/>
+          </a:p>
+        </p:txBody>
+      </p:sp>
+      <p:sp>
+        <p:nvSpPr>
+          <p:cNvPr id="16" name="Text 14"/>
+          <p:cNvSpPr/>
+          <p:nvPr/>
+        </p:nvSpPr>
+        <p:spPr>
+          <a:xfrm>
+            <a:off x="7132320" y="1728216"/>
+            <a:ext cx="4389120" cy="621792"/>
+          </a:xfrm>
+          <a:prstGeom prst="rect">
+            <a:avLst/>
+          </a:prstGeom>
+          <a:noFill/>
+          <a:ln/>
+        </p:spPr>
+        <p:txBody>
+          <a:bodyPr wrap="square" lIns="0" tIns="0" rIns="0" bIns="0" rtlCol="0" anchor="ctr"/>
+          <a:lstStyle/>
+          <a:p>
+            <a:pPr indent="0" marL="0">
+              <a:buNone/>
+            </a:pPr>
+            <a:r>
+              <a:rPr lang="en-US" sz="1100" dirty="0">
                 <a:solidFill>
                   <a:srgbClr val="9DB8A6"/>
                 </a:solidFill>
@@ -2520,24 +2598,24 @@
               </a:rPr>
               <a:t>Students meet the mystery on Chromebooks; farm chapters quietly cache to their phones.</a:t>
             </a:r>
-            <a:endParaRPr lang="en-US" sz="1150" dirty="0"/>
-          </a:p>
-        </p:txBody>
-      </p:sp>
-      <p:sp>
-        <p:nvSpPr>
-          <p:cNvPr id="15" name="Shape 13"/>
-          <p:cNvSpPr/>
-          <p:nvPr/>
-        </p:nvSpPr>
-        <p:spPr>
-          <a:xfrm>
-            <a:off x="6263640" y="2724912"/>
-            <a:ext cx="5394960" cy="1261872"/>
+            <a:endParaRPr lang="en-US" sz="1100" dirty="0"/>
+          </a:p>
+        </p:txBody>
+      </p:sp>
+      <p:sp>
+        <p:nvSpPr>
+          <p:cNvPr id="17" name="Shape 15"/>
+          <p:cNvSpPr/>
+          <p:nvPr/>
+        </p:nvSpPr>
+        <p:spPr>
+          <a:xfrm>
+            <a:off x="6263640" y="2514600"/>
+            <a:ext cx="5394960" cy="1060704"/>
           </a:xfrm>
           <a:prstGeom prst="roundRect">
             <a:avLst>
-              <a:gd name="adj" fmla="val 6522"/>
+              <a:gd name="adj" fmla="val 7759"/>
             </a:avLst>
           </a:prstGeom>
           <a:solidFill>
@@ -2553,14 +2631,14 @@
       </p:sp>
       <p:sp>
         <p:nvSpPr>
-          <p:cNvPr id="16" name="Shape 14"/>
-          <p:cNvSpPr/>
-          <p:nvPr/>
-        </p:nvSpPr>
-        <p:spPr>
-          <a:xfrm>
-            <a:off x="6492240" y="3108960"/>
-            <a:ext cx="502920" cy="502920"/>
+          <p:cNvPr id="18" name="Shape 16"/>
+          <p:cNvSpPr/>
+          <p:nvPr/>
+        </p:nvSpPr>
+        <p:spPr>
+          <a:xfrm>
+            <a:off x="6492240" y="2807208"/>
+            <a:ext cx="457200" cy="457200"/>
           </a:xfrm>
           <a:prstGeom prst="ellipse">
             <a:avLst/>
@@ -2578,14 +2656,14 @@
       </p:sp>
       <p:sp>
         <p:nvSpPr>
-          <p:cNvPr id="17" name="Text 15"/>
-          <p:cNvSpPr/>
-          <p:nvPr/>
-        </p:nvSpPr>
-        <p:spPr>
-          <a:xfrm>
-            <a:off x="6492240" y="3108960"/>
-            <a:ext cx="502920" cy="502920"/>
+          <p:cNvPr id="19" name="Text 17"/>
+          <p:cNvSpPr/>
+          <p:nvPr/>
+        </p:nvSpPr>
+        <p:spPr>
+          <a:xfrm>
+            <a:off x="6492240" y="2807208"/>
+            <a:ext cx="457200" cy="457200"/>
           </a:xfrm>
           <a:prstGeom prst="rect">
             <a:avLst/>
@@ -2601,7 +2679,7 @@
               <a:buNone/>
             </a:pPr>
             <a:r>
-              <a:rPr lang="en-US" sz="1800" b="1" dirty="0">
+              <a:rPr lang="en-US" sz="1600" b="1" dirty="0">
                 <a:solidFill>
                   <a:srgbClr val="F5B942"/>
                 </a:solidFill>
@@ -2611,36 +2689,36 @@
               </a:rPr>
               <a:t>2</a:t>
             </a:r>
-            <a:endParaRPr lang="en-US" sz="1800" dirty="0"/>
-          </a:p>
-        </p:txBody>
-      </p:sp>
-      <p:sp>
-        <p:nvSpPr>
-          <p:cNvPr id="18" name="Text 16"/>
-          <p:cNvSpPr/>
-          <p:nvPr/>
-        </p:nvSpPr>
-        <p:spPr>
-          <a:xfrm>
-            <a:off x="7178040" y="2871216"/>
-            <a:ext cx="4343400" cy="292608"/>
-          </a:xfrm>
-          <a:prstGeom prst="rect">
-            <a:avLst/>
-          </a:prstGeom>
-          <a:noFill/>
-          <a:ln/>
-        </p:spPr>
-        <p:txBody>
-          <a:bodyPr wrap="square" lIns="0" tIns="0" rIns="0" bIns="0" rtlCol="0" anchor="ctr"/>
-          <a:lstStyle/>
-          <a:p>
-            <a:pPr indent="0" marL="0">
-              <a:buNone/>
-            </a:pPr>
-            <a:r>
-              <a:rPr lang="en-US" sz="1400" b="1" dirty="0">
+            <a:endParaRPr lang="en-US" sz="1600" dirty="0"/>
+          </a:p>
+        </p:txBody>
+      </p:sp>
+      <p:sp>
+        <p:nvSpPr>
+          <p:cNvPr id="20" name="Text 18"/>
+          <p:cNvSpPr/>
+          <p:nvPr/>
+        </p:nvSpPr>
+        <p:spPr>
+          <a:xfrm>
+            <a:off x="7132320" y="2624328"/>
+            <a:ext cx="4389120" cy="274320"/>
+          </a:xfrm>
+          <a:prstGeom prst="rect">
+            <a:avLst/>
+          </a:prstGeom>
+          <a:noFill/>
+          <a:ln/>
+        </p:spPr>
+        <p:txBody>
+          <a:bodyPr wrap="square" lIns="0" tIns="0" rIns="0" bIns="0" rtlCol="0" anchor="ctr"/>
+          <a:lstStyle/>
+          <a:p>
+            <a:pPr indent="0" marL="0">
+              <a:buNone/>
+            </a:pPr>
+            <a:r>
+              <a:rPr lang="en-US" sz="1300" b="1" dirty="0">
                 <a:solidFill>
                   <a:srgbClr val="F8D183"/>
                 </a:solidFill>
@@ -2650,36 +2728,36 @@
               </a:rPr>
               <a:t>At the farm — the expedition</a:t>
             </a:r>
-            <a:endParaRPr lang="en-US" sz="1400" dirty="0"/>
-          </a:p>
-        </p:txBody>
-      </p:sp>
-      <p:sp>
-        <p:nvSpPr>
-          <p:cNvPr id="19" name="Text 17"/>
-          <p:cNvSpPr/>
-          <p:nvPr/>
-        </p:nvSpPr>
-        <p:spPr>
-          <a:xfrm>
-            <a:off x="7178040" y="3182112"/>
-            <a:ext cx="4343400" cy="731520"/>
-          </a:xfrm>
-          <a:prstGeom prst="rect">
-            <a:avLst/>
-          </a:prstGeom>
-          <a:noFill/>
-          <a:ln/>
-        </p:spPr>
-        <p:txBody>
-          <a:bodyPr wrap="square" lIns="0" tIns="0" rIns="0" bIns="0" rtlCol="0" anchor="ctr"/>
-          <a:lstStyle/>
-          <a:p>
-            <a:pPr indent="0" marL="0">
-              <a:buNone/>
-            </a:pPr>
-            <a:r>
-              <a:rPr lang="en-US" sz="1150" dirty="0">
+            <a:endParaRPr lang="en-US" sz="1300" dirty="0"/>
+          </a:p>
+        </p:txBody>
+      </p:sp>
+      <p:sp>
+        <p:nvSpPr>
+          <p:cNvPr id="21" name="Text 19"/>
+          <p:cNvSpPr/>
+          <p:nvPr/>
+        </p:nvSpPr>
+        <p:spPr>
+          <a:xfrm>
+            <a:off x="7132320" y="2916936"/>
+            <a:ext cx="4389120" cy="621792"/>
+          </a:xfrm>
+          <a:prstGeom prst="rect">
+            <a:avLst/>
+          </a:prstGeom>
+          <a:noFill/>
+          <a:ln/>
+        </p:spPr>
+        <p:txBody>
+          <a:bodyPr wrap="square" lIns="0" tIns="0" rIns="0" bIns="0" rtlCol="0" anchor="ctr"/>
+          <a:lstStyle/>
+          <a:p>
+            <a:pPr indent="0" marL="0">
+              <a:buNone/>
+            </a:pPr>
+            <a:r>
+              <a:rPr lang="en-US" sz="1100" dirty="0">
                 <a:solidFill>
                   <a:srgbClr val="9DB8A6"/>
                 </a:solidFill>
@@ -2687,26 +2765,26 @@
                 <a:ea typeface="Calibri" pitchFamily="34" charset="-122"/>
                 <a:cs typeface="Calibri" pitchFamily="34" charset="-120"/>
               </a:rPr>
-              <a:t>QR scans at the barn, field &amp; market stand unlock chapters tied to what students stand in front of.</a:t>
-            </a:r>
-            <a:endParaRPr lang="en-US" sz="1150" dirty="0"/>
-          </a:p>
-        </p:txBody>
-      </p:sp>
-      <p:sp>
-        <p:nvSpPr>
-          <p:cNvPr id="20" name="Shape 18"/>
-          <p:cNvSpPr/>
-          <p:nvPr/>
-        </p:nvSpPr>
-        <p:spPr>
-          <a:xfrm>
-            <a:off x="6263640" y="4123944"/>
-            <a:ext cx="5394960" cy="1261872"/>
+              <a:t>QR scans at real farm stations unlock chapters — the clues live in the physical world.</a:t>
+            </a:r>
+            <a:endParaRPr lang="en-US" sz="1100" dirty="0"/>
+          </a:p>
+        </p:txBody>
+      </p:sp>
+      <p:sp>
+        <p:nvSpPr>
+          <p:cNvPr id="22" name="Shape 20"/>
+          <p:cNvSpPr/>
+          <p:nvPr/>
+        </p:nvSpPr>
+        <p:spPr>
+          <a:xfrm>
+            <a:off x="6263640" y="3703320"/>
+            <a:ext cx="5394960" cy="1060704"/>
           </a:xfrm>
           <a:prstGeom prst="roundRect">
             <a:avLst>
-              <a:gd name="adj" fmla="val 6522"/>
+              <a:gd name="adj" fmla="val 7759"/>
             </a:avLst>
           </a:prstGeom>
           <a:solidFill>
@@ -2722,14 +2800,14 @@
       </p:sp>
       <p:sp>
         <p:nvSpPr>
-          <p:cNvPr id="21" name="Shape 19"/>
-          <p:cNvSpPr/>
-          <p:nvPr/>
-        </p:nvSpPr>
-        <p:spPr>
-          <a:xfrm>
-            <a:off x="6492240" y="4507992"/>
-            <a:ext cx="502920" cy="502920"/>
+          <p:cNvPr id="23" name="Shape 21"/>
+          <p:cNvSpPr/>
+          <p:nvPr/>
+        </p:nvSpPr>
+        <p:spPr>
+          <a:xfrm>
+            <a:off x="6492240" y="3995928"/>
+            <a:ext cx="457200" cy="457200"/>
           </a:xfrm>
           <a:prstGeom prst="ellipse">
             <a:avLst/>
@@ -2747,14 +2825,14 @@
       </p:sp>
       <p:sp>
         <p:nvSpPr>
-          <p:cNvPr id="22" name="Text 20"/>
-          <p:cNvSpPr/>
-          <p:nvPr/>
-        </p:nvSpPr>
-        <p:spPr>
-          <a:xfrm>
-            <a:off x="6492240" y="4507992"/>
-            <a:ext cx="502920" cy="502920"/>
+          <p:cNvPr id="24" name="Text 22"/>
+          <p:cNvSpPr/>
+          <p:nvPr/>
+        </p:nvSpPr>
+        <p:spPr>
+          <a:xfrm>
+            <a:off x="6492240" y="3995928"/>
+            <a:ext cx="457200" cy="457200"/>
           </a:xfrm>
           <a:prstGeom prst="rect">
             <a:avLst/>
@@ -2770,7 +2848,7 @@
               <a:buNone/>
             </a:pPr>
             <a:r>
-              <a:rPr lang="en-US" sz="1800" b="1" dirty="0">
+              <a:rPr lang="en-US" sz="1600" b="1" dirty="0">
                 <a:solidFill>
                   <a:srgbClr val="F5B942"/>
                 </a:solidFill>
@@ -2780,36 +2858,36 @@
               </a:rPr>
               <a:t>3</a:t>
             </a:r>
-            <a:endParaRPr lang="en-US" sz="1800" dirty="0"/>
-          </a:p>
-        </p:txBody>
-      </p:sp>
-      <p:sp>
-        <p:nvSpPr>
-          <p:cNvPr id="23" name="Text 21"/>
-          <p:cNvSpPr/>
-          <p:nvPr/>
-        </p:nvSpPr>
-        <p:spPr>
-          <a:xfrm>
-            <a:off x="7178040" y="4270248"/>
-            <a:ext cx="4343400" cy="292608"/>
-          </a:xfrm>
-          <a:prstGeom prst="rect">
-            <a:avLst/>
-          </a:prstGeom>
-          <a:noFill/>
-          <a:ln/>
-        </p:spPr>
-        <p:txBody>
-          <a:bodyPr wrap="square" lIns="0" tIns="0" rIns="0" bIns="0" rtlCol="0" anchor="ctr"/>
-          <a:lstStyle/>
-          <a:p>
-            <a:pPr indent="0" marL="0">
-              <a:buNone/>
-            </a:pPr>
-            <a:r>
-              <a:rPr lang="en-US" sz="1400" b="1" dirty="0">
+            <a:endParaRPr lang="en-US" sz="1600" dirty="0"/>
+          </a:p>
+        </p:txBody>
+      </p:sp>
+      <p:sp>
+        <p:nvSpPr>
+          <p:cNvPr id="25" name="Text 23"/>
+          <p:cNvSpPr/>
+          <p:nvPr/>
+        </p:nvSpPr>
+        <p:spPr>
+          <a:xfrm>
+            <a:off x="7132320" y="3813048"/>
+            <a:ext cx="4389120" cy="274320"/>
+          </a:xfrm>
+          <a:prstGeom prst="rect">
+            <a:avLst/>
+          </a:prstGeom>
+          <a:noFill/>
+          <a:ln/>
+        </p:spPr>
+        <p:txBody>
+          <a:bodyPr wrap="square" lIns="0" tIns="0" rIns="0" bIns="0" rtlCol="0" anchor="ctr"/>
+          <a:lstStyle/>
+          <a:p>
+            <a:pPr indent="0" marL="0">
+              <a:buNone/>
+            </a:pPr>
+            <a:r>
+              <a:rPr lang="en-US" sz="1300" b="1" dirty="0">
                 <a:solidFill>
                   <a:srgbClr val="F8D183"/>
                 </a:solidFill>
@@ -2819,36 +2897,36 @@
               </a:rPr>
               <a:t>Back in class — the finale</a:t>
             </a:r>
-            <a:endParaRPr lang="en-US" sz="1400" dirty="0"/>
-          </a:p>
-        </p:txBody>
-      </p:sp>
-      <p:sp>
-        <p:nvSpPr>
-          <p:cNvPr id="24" name="Text 22"/>
-          <p:cNvSpPr/>
-          <p:nvPr/>
-        </p:nvSpPr>
-        <p:spPr>
-          <a:xfrm>
-            <a:off x="7178040" y="4581144"/>
-            <a:ext cx="4343400" cy="731520"/>
-          </a:xfrm>
-          <a:prstGeom prst="rect">
-            <a:avLst/>
-          </a:prstGeom>
-          <a:noFill/>
-          <a:ln/>
-        </p:spPr>
-        <p:txBody>
-          <a:bodyPr wrap="square" lIns="0" tIns="0" rIns="0" bIns="0" rtlCol="0" anchor="ctr"/>
-          <a:lstStyle/>
-          <a:p>
-            <a:pPr indent="0" marL="0">
-              <a:buNone/>
-            </a:pPr>
-            <a:r>
-              <a:rPr lang="en-US" sz="1150" dirty="0">
+            <a:endParaRPr lang="en-US" sz="1300" dirty="0"/>
+          </a:p>
+        </p:txBody>
+      </p:sp>
+      <p:sp>
+        <p:nvSpPr>
+          <p:cNvPr id="26" name="Text 24"/>
+          <p:cNvSpPr/>
+          <p:nvPr/>
+        </p:nvSpPr>
+        <p:spPr>
+          <a:xfrm>
+            <a:off x="7132320" y="4105656"/>
+            <a:ext cx="4389120" cy="621792"/>
+          </a:xfrm>
+          <a:prstGeom prst="rect">
+            <a:avLst/>
+          </a:prstGeom>
+          <a:noFill/>
+          <a:ln/>
+        </p:spPr>
+        <p:txBody>
+          <a:bodyPr wrap="square" lIns="0" tIns="0" rIns="0" bIns="0" rtlCol="0" anchor="ctr"/>
+          <a:lstStyle/>
+          <a:p>
+            <a:pPr indent="0" marL="0">
+              <a:buNone/>
+            </a:pPr>
+            <a:r>
+              <a:rPr lang="en-US" sz="1100" dirty="0">
                 <a:solidFill>
                   <a:srgbClr val="9DB8A6"/>
                 </a:solidFill>
@@ -2858,24 +2936,24 @@
               </a:rPr>
               <a:t>Every group's ending reflects its choices; a reflection chapter ties it to the curriculum.</a:t>
             </a:r>
-            <a:endParaRPr lang="en-US" sz="1150" dirty="0"/>
-          </a:p>
-        </p:txBody>
-      </p:sp>
-      <p:sp>
-        <p:nvSpPr>
-          <p:cNvPr id="25" name="Shape 23"/>
-          <p:cNvSpPr/>
-          <p:nvPr/>
-        </p:nvSpPr>
-        <p:spPr>
-          <a:xfrm>
-            <a:off x="548640" y="6172200"/>
-            <a:ext cx="2377440" cy="384048"/>
+            <a:endParaRPr lang="en-US" sz="1100" dirty="0"/>
+          </a:p>
+        </p:txBody>
+      </p:sp>
+      <p:sp>
+        <p:nvSpPr>
+          <p:cNvPr id="27" name="Shape 25"/>
+          <p:cNvSpPr/>
+          <p:nvPr/>
+        </p:nvSpPr>
+        <p:spPr>
+          <a:xfrm>
+            <a:off x="6263640" y="4892040"/>
+            <a:ext cx="5394960" cy="1060704"/>
           </a:xfrm>
           <a:prstGeom prst="roundRect">
             <a:avLst>
-              <a:gd name="adj" fmla="val 50000"/>
+              <a:gd name="adj" fmla="val 7759"/>
             </a:avLst>
           </a:prstGeom>
           <a:solidFill>
@@ -2891,14 +2969,63 @@
       </p:sp>
       <p:sp>
         <p:nvSpPr>
-          <p:cNvPr id="26" name="Text 24"/>
-          <p:cNvSpPr/>
-          <p:nvPr/>
-        </p:nvSpPr>
-        <p:spPr>
-          <a:xfrm>
-            <a:off x="548640" y="6172200"/>
-            <a:ext cx="2377440" cy="384048"/>
+          <p:cNvPr id="28" name="Shape 26"/>
+          <p:cNvSpPr/>
+          <p:nvPr/>
+        </p:nvSpPr>
+        <p:spPr>
+          <a:xfrm>
+            <a:off x="6263640" y="4892040"/>
+            <a:ext cx="5394960" cy="1060704"/>
+          </a:xfrm>
+          <a:prstGeom prst="roundRect">
+            <a:avLst>
+              <a:gd name="adj" fmla="val 7759"/>
+            </a:avLst>
+          </a:prstGeom>
+          <a:ln w="19050">
+            <a:solidFill>
+              <a:srgbClr val="4CC776"/>
+            </a:solidFill>
+            <a:prstDash val="solid"/>
+          </a:ln>
+        </p:spPr>
+      </p:sp>
+      <p:sp>
+        <p:nvSpPr>
+          <p:cNvPr id="29" name="Shape 27"/>
+          <p:cNvSpPr/>
+          <p:nvPr/>
+        </p:nvSpPr>
+        <p:spPr>
+          <a:xfrm>
+            <a:off x="6492240" y="5184648"/>
+            <a:ext cx="457200" cy="457200"/>
+          </a:xfrm>
+          <a:prstGeom prst="ellipse">
+            <a:avLst/>
+          </a:prstGeom>
+          <a:solidFill>
+            <a:srgbClr val="0C1A12"/>
+          </a:solidFill>
+          <a:ln w="19050">
+            <a:solidFill>
+              <a:srgbClr val="4CC776"/>
+            </a:solidFill>
+            <a:prstDash val="solid"/>
+          </a:ln>
+        </p:spPr>
+      </p:sp>
+      <p:sp>
+        <p:nvSpPr>
+          <p:cNvPr id="30" name="Text 28"/>
+          <p:cNvSpPr/>
+          <p:nvPr/>
+        </p:nvSpPr>
+        <p:spPr>
+          <a:xfrm>
+            <a:off x="6492240" y="5184648"/>
+            <a:ext cx="457200" cy="457200"/>
           </a:xfrm>
           <a:prstGeom prst="rect">
             <a:avLst/>
@@ -2914,29 +3041,107 @@
               <a:buNone/>
             </a:pPr>
             <a:r>
-              <a:rPr lang="en-US" sz="1150" b="1" dirty="0">
-                <a:solidFill>
-                  <a:srgbClr val="F8D183"/>
+              <a:rPr lang="en-US" sz="1600" b="1" dirty="0">
+                <a:solidFill>
+                  <a:srgbClr val="4CC776"/>
+                </a:solidFill>
+                <a:latin typeface="Arial" pitchFamily="34" charset="0"/>
+                <a:ea typeface="Arial" pitchFamily="34" charset="-122"/>
+                <a:cs typeface="Arial" pitchFamily="34" charset="-120"/>
+              </a:rPr>
+              <a:t>4</a:t>
+            </a:r>
+            <a:endParaRPr lang="en-US" sz="1600" dirty="0"/>
+          </a:p>
+        </p:txBody>
+      </p:sp>
+      <p:sp>
+        <p:nvSpPr>
+          <p:cNvPr id="31" name="Text 29"/>
+          <p:cNvSpPr/>
+          <p:nvPr/>
+        </p:nvSpPr>
+        <p:spPr>
+          <a:xfrm>
+            <a:off x="7132320" y="5001768"/>
+            <a:ext cx="4389120" cy="274320"/>
+          </a:xfrm>
+          <a:prstGeom prst="rect">
+            <a:avLst/>
+          </a:prstGeom>
+          <a:noFill/>
+          <a:ln/>
+        </p:spPr>
+        <p:txBody>
+          <a:bodyPr wrap="square" lIns="0" tIns="0" rIns="0" bIns="0" rtlCol="0" anchor="ctr"/>
+          <a:lstStyle/>
+          <a:p>
+            <a:pPr indent="0" marL="0">
+              <a:buNone/>
+            </a:pPr>
+            <a:r>
+              <a:rPr lang="en-US" sz="1300" b="1" dirty="0">
+                <a:solidFill>
+                  <a:srgbClr val="4CC776"/>
+                </a:solidFill>
+                <a:latin typeface="Arial" pitchFamily="34" charset="0"/>
+                <a:ea typeface="Arial" pitchFamily="34" charset="-122"/>
+                <a:cs typeface="Arial" pitchFamily="34" charset="-120"/>
+              </a:rPr>
+              <a:t>Grow-to-Give — the harvest (extension)</a:t>
+            </a:r>
+            <a:endParaRPr lang="en-US" sz="1300" dirty="0"/>
+          </a:p>
+        </p:txBody>
+      </p:sp>
+      <p:sp>
+        <p:nvSpPr>
+          <p:cNvPr id="32" name="Text 30"/>
+          <p:cNvSpPr/>
+          <p:nvPr/>
+        </p:nvSpPr>
+        <p:spPr>
+          <a:xfrm>
+            <a:off x="7132320" y="5294376"/>
+            <a:ext cx="4389120" cy="621792"/>
+          </a:xfrm>
+          <a:prstGeom prst="rect">
+            <a:avLst/>
+          </a:prstGeom>
+          <a:noFill/>
+          <a:ln/>
+        </p:spPr>
+        <p:txBody>
+          <a:bodyPr wrap="square" lIns="0" tIns="0" rIns="0" bIns="0" rtlCol="0" anchor="ctr"/>
+          <a:lstStyle/>
+          <a:p>
+            <a:pPr indent="0" marL="0">
+              <a:buNone/>
+            </a:pPr>
+            <a:r>
+              <a:rPr lang="en-US" sz="1100" dirty="0">
+                <a:solidFill>
+                  <a:srgbClr val="9DB8A6"/>
                 </a:solidFill>
                 <a:latin typeface="Calibri" pitchFamily="34" charset="0"/>
                 <a:ea typeface="Calibri" pitchFamily="34" charset="-122"/>
                 <a:cs typeface="Calibri" pitchFamily="34" charset="-120"/>
               </a:rPr>
-              <a:t>&lt; $2 per story pack</a:t>
-            </a:r>
-            <a:endParaRPr lang="en-US" sz="1150" dirty="0"/>
-          </a:p>
-        </p:txBody>
-      </p:sp>
-      <p:sp>
-        <p:nvSpPr>
-          <p:cNvPr id="27" name="Shape 25"/>
-          <p:cNvSpPr/>
-          <p:nvPr/>
-        </p:nvSpPr>
-        <p:spPr>
-          <a:xfrm>
-            <a:off x="3154680" y="6172200"/>
+              <a:t>Chapters unlock at planting, first sprouts &amp; harvest — ending in a real food-bank donation.</a:t>
+            </a:r>
+            <a:endParaRPr lang="en-US" sz="1100" dirty="0"/>
+          </a:p>
+        </p:txBody>
+      </p:sp>
+      <p:sp>
+        <p:nvSpPr>
+          <p:cNvPr id="33" name="Shape 31"/>
+          <p:cNvSpPr/>
+          <p:nvPr/>
+        </p:nvSpPr>
+        <p:spPr>
+          <a:xfrm>
+            <a:off x="548640" y="6172200"/>
             <a:ext cx="2377440" cy="384048"/>
           </a:xfrm>
           <a:prstGeom prst="roundRect">
@@ -2957,13 +3162,13 @@
       </p:sp>
       <p:sp>
         <p:nvSpPr>
-          <p:cNvPr id="28" name="Text 26"/>
-          <p:cNvSpPr/>
-          <p:nvPr/>
-        </p:nvSpPr>
-        <p:spPr>
-          <a:xfrm>
-            <a:off x="3154680" y="6172200"/>
+          <p:cNvPr id="34" name="Text 32"/>
+          <p:cNvSpPr/>
+          <p:nvPr/>
+        </p:nvSpPr>
+        <p:spPr>
+          <a:xfrm>
+            <a:off x="548640" y="6172200"/>
             <a:ext cx="2377440" cy="384048"/>
           </a:xfrm>
           <a:prstGeom prst="rect">
@@ -2988,7 +3193,7 @@
                 <a:ea typeface="Calibri" pitchFamily="34" charset="-122"/>
                 <a:cs typeface="Calibri" pitchFamily="34" charset="-120"/>
               </a:rPr>
-              <a:t>&lt; $50 / month pilot</a:t>
+              <a:t>&lt; $2 per story pack</a:t>
             </a:r>
             <a:endParaRPr lang="en-US" sz="1150" dirty="0"/>
           </a:p>
@@ -2996,14 +3201,14 @@
       </p:sp>
       <p:sp>
         <p:nvSpPr>
-          <p:cNvPr id="29" name="Shape 27"/>
-          <p:cNvSpPr/>
-          <p:nvPr/>
-        </p:nvSpPr>
-        <p:spPr>
-          <a:xfrm>
-            <a:off x="5760720" y="6172200"/>
-            <a:ext cx="2743200" cy="384048"/>
+          <p:cNvPr id="35" name="Shape 33"/>
+          <p:cNvSpPr/>
+          <p:nvPr/>
+        </p:nvSpPr>
+        <p:spPr>
+          <a:xfrm>
+            <a:off x="3154680" y="6172200"/>
+            <a:ext cx="2377440" cy="384048"/>
           </a:xfrm>
           <a:prstGeom prst="roundRect">
             <a:avLst>
@@ -3023,14 +3228,14 @@
       </p:sp>
       <p:sp>
         <p:nvSpPr>
-          <p:cNvPr id="30" name="Text 28"/>
-          <p:cNvSpPr/>
-          <p:nvPr/>
-        </p:nvSpPr>
-        <p:spPr>
-          <a:xfrm>
-            <a:off x="5760720" y="6172200"/>
-            <a:ext cx="2743200" cy="384048"/>
+          <p:cNvPr id="36" name="Text 34"/>
+          <p:cNvSpPr/>
+          <p:nvPr/>
+        </p:nvSpPr>
+        <p:spPr>
+          <a:xfrm>
+            <a:off x="3154680" y="6172200"/>
+            <a:ext cx="2377440" cy="384048"/>
           </a:xfrm>
           <a:prstGeom prst="rect">
             <a:avLst/>
@@ -3054,7 +3259,7 @@
                 <a:ea typeface="Calibri" pitchFamily="34" charset="-122"/>
                 <a:cs typeface="Calibri" pitchFamily="34" charset="-120"/>
               </a:rPr>
-              <a:t>Groups of 2–4 · one phone</a:t>
+              <a:t>&lt; $50 / month pilot</a:t>
             </a:r>
             <a:endParaRPr lang="en-US" sz="1150" dirty="0"/>
           </a:p>
@@ -3062,14 +3267,14 @@
       </p:sp>
       <p:sp>
         <p:nvSpPr>
-          <p:cNvPr id="31" name="Shape 29"/>
-          <p:cNvSpPr/>
-          <p:nvPr/>
-        </p:nvSpPr>
-        <p:spPr>
-          <a:xfrm>
-            <a:off x="8732520" y="6172200"/>
-            <a:ext cx="2926080" cy="384048"/>
+          <p:cNvPr id="37" name="Shape 35"/>
+          <p:cNvSpPr/>
+          <p:nvPr/>
+        </p:nvSpPr>
+        <p:spPr>
+          <a:xfrm>
+            <a:off x="5760720" y="6172200"/>
+            <a:ext cx="2743200" cy="384048"/>
           </a:xfrm>
           <a:prstGeom prst="roundRect">
             <a:avLst>
@@ -3089,7 +3294,73 @@
       </p:sp>
       <p:sp>
         <p:nvSpPr>
-          <p:cNvPr id="32" name="Text 30"/>
+          <p:cNvPr id="38" name="Text 36"/>
+          <p:cNvSpPr/>
+          <p:nvPr/>
+        </p:nvSpPr>
+        <p:spPr>
+          <a:xfrm>
+            <a:off x="5760720" y="6172200"/>
+            <a:ext cx="2743200" cy="384048"/>
+          </a:xfrm>
+          <a:prstGeom prst="rect">
+            <a:avLst/>
+          </a:prstGeom>
+          <a:noFill/>
+          <a:ln/>
+        </p:spPr>
+        <p:txBody>
+          <a:bodyPr wrap="square" lIns="0" tIns="0" rIns="0" bIns="0" rtlCol="0" anchor="ctr"/>
+          <a:lstStyle/>
+          <a:p>
+            <a:pPr algn="ctr" indent="0" marL="0">
+              <a:buNone/>
+            </a:pPr>
+            <a:r>
+              <a:rPr lang="en-US" sz="1150" b="1" dirty="0">
+                <a:solidFill>
+                  <a:srgbClr val="F8D183"/>
+                </a:solidFill>
+                <a:latin typeface="Calibri" pitchFamily="34" charset="0"/>
+                <a:ea typeface="Calibri" pitchFamily="34" charset="-122"/>
+                <a:cs typeface="Calibri" pitchFamily="34" charset="-120"/>
+              </a:rPr>
+              <a:t>Groups of 2–4 · one phone</a:t>
+            </a:r>
+            <a:endParaRPr lang="en-US" sz="1150" dirty="0"/>
+          </a:p>
+        </p:txBody>
+      </p:sp>
+      <p:sp>
+        <p:nvSpPr>
+          <p:cNvPr id="39" name="Shape 37"/>
+          <p:cNvSpPr/>
+          <p:nvPr/>
+        </p:nvSpPr>
+        <p:spPr>
+          <a:xfrm>
+            <a:off x="8732520" y="6172200"/>
+            <a:ext cx="2926080" cy="384048"/>
+          </a:xfrm>
+          <a:prstGeom prst="roundRect">
+            <a:avLst>
+              <a:gd name="adj" fmla="val 50000"/>
+            </a:avLst>
+          </a:prstGeom>
+          <a:solidFill>
+            <a:srgbClr val="162C20"/>
+          </a:solidFill>
+          <a:ln w="12700">
+            <a:solidFill>
+              <a:srgbClr val="24402F"/>
+            </a:solidFill>
+            <a:prstDash val="solid"/>
+          </a:ln>
+        </p:spPr>
+      </p:sp>
+      <p:sp>
+        <p:nvSpPr>
+          <p:cNvPr id="40" name="Text 38"/>
           <p:cNvSpPr/>
           <p:nvPr/>
         </p:nvSpPr>
@@ -4273,7 +4544,7 @@
                 <a:ea typeface="Calibri" pitchFamily="34" charset="-122"/>
                 <a:cs typeface="Calibri" pitchFamily="34" charset="-120"/>
               </a:rPr>
-              <a:t>1 real interview transcribed &amp; synthesized (no-fabrication protocol) · 4 interview guides ready.</a:t>
+              <a:t>1 real interview synthesized (no-fabrication protocol) · 4 guides ready · backdrop: 14.1M U.S. children food-insecure (USDA 2024).</a:t>
             </a:r>
             <a:endParaRPr lang="en-US" sz="1300" dirty="0"/>
           </a:p>

</xml_diff>